<commit_message>
Keep author's kill-chain stage colour progression
Slide 7 only. The seven stage headers now run gold, green, blue, blue, purple, purple, coral, so the row reads as escalation rather than seven identical labels. This mirrors the colour progression on the rebuilt timeline slide.

Authored by hand in PowerPoint and preserved verbatim; no other slide part differs from the previous commit.
</commit_message>
<xml_diff>
--- a/STUDENT-GUIDES/Cyber_Defense_KQL_Workshop_v2.pptx
+++ b/STUDENT-GUIDES/Cyber_Defense_KQL_Workshop_v2.pptx
@@ -38024,7 +38024,7 @@
         <p:spPr>
           <a:xfrm>
             <a:off x="612648" y="1920240"/>
-            <a:ext cx="1382050" cy="640080"/>
+            <a:ext cx="1382050" cy="169277"/>
           </a:xfrm>
           <a:prstGeom prst="rect">
             <a:avLst/>
@@ -38049,9 +38049,9 @@
               </a:spcAft>
             </a:pPr>
             <a:r>
-              <a:rPr sz="1100" b="1" i="0">
-                <a:solidFill>
-                  <a:srgbClr val="8A93A0"/>
+              <a:rPr sz="1100" b="1" i="0" dirty="0">
+                <a:solidFill>
+                  <a:schemeClr val="accent6"/>
                 </a:solidFill>
                 <a:latin typeface="Consolas"/>
                 <a:cs typeface="Consolas"/>
@@ -38209,7 +38209,7 @@
         <p:spPr>
           <a:xfrm>
             <a:off x="2195866" y="1920240"/>
-            <a:ext cx="1382050" cy="640080"/>
+            <a:ext cx="1382050" cy="169277"/>
           </a:xfrm>
           <a:prstGeom prst="rect">
             <a:avLst/>
@@ -38234,9 +38234,11 @@
               </a:spcAft>
             </a:pPr>
             <a:r>
-              <a:rPr sz="1100" b="1" i="0">
-                <a:solidFill>
-                  <a:srgbClr val="8A93A0"/>
+              <a:rPr sz="1100" b="1" i="0" dirty="0">
+                <a:solidFill>
+                  <a:schemeClr val="accent3">
+                    <a:lumMod val="75000"/>
+                  </a:schemeClr>
                 </a:solidFill>
                 <a:latin typeface="Consolas"/>
                 <a:cs typeface="Consolas"/>

</xml_diff>